<commit_message>
Slide deck: fix title and model-slide overlaps
Co-Authored-By: Claude Opus 5.5 <noreply@anthropic.com>
Claude-Session: https://claude.ai/code/session_01UC4hXoJUrtqj2AaZYG4sDJ
</commit_message>
<xml_diff>
--- a/docs/deck/GMAPS_Open_Agent_2026.pptx
+++ b/docs/deck/GMAPS_Open_Agent_2026.pptx
@@ -3149,7 +3149,7 @@
         </p:nvSpPr>
         <p:spPr>
           <a:xfrm>
-            <a:off x="548640" y="1600200"/>
+            <a:off x="548640" y="1965960"/>
             <a:ext cx="10972800" cy="548640"/>
           </a:xfrm>
           <a:prstGeom prst="rect">
@@ -3183,7 +3183,7 @@
         </p:nvSpPr>
         <p:spPr>
           <a:xfrm>
-            <a:off x="548640" y="2468880"/>
+            <a:off x="548640" y="2834640"/>
             <a:ext cx="10972800" cy="1463040"/>
           </a:xfrm>
           <a:prstGeom prst="rect">
@@ -5161,7 +5161,7 @@
                 </a:solidFill>
                 <a:latin typeface="Calibri"/>
               </a:rPr>
-              <a:t>NVIDIA Nemotron 30B via Meterless Nightshift (new)</a:t>
+              <a:t>Nemotron 30B via Nightshift (new)</a:t>
             </a:r>
           </a:p>
         </p:txBody>

</xml_diff>

<commit_message>
Deck: Explainer + Critic loop on the workflow slide
Co-Authored-By: Claude Opus 5.5 <noreply@anthropic.com>
Claude-Session: https://claude.ai/code/session_01UC4hXoJUrtqj2AaZYG4sDJ
</commit_message>
<xml_diff>
--- a/docs/deck/GMAPS_Open_Agent_2026.pptx
+++ b/docs/deck/GMAPS_Open_Agent_2026.pptx
@@ -4768,7 +4768,7 @@
                   <a:srgbClr val="A78BFA"/>
                 </a:solidFill>
               </a:rPr>
-              <a:t>Explainer</a:t>
+              <a:t>Explainer + Critic</a:t>
             </a:r>
           </a:p>
           <a:p>
@@ -4778,7 +4778,7 @@
                   <a:srgbClr val="EEF1F5"/>
                 </a:solidFill>
               </a:rPr>
-              <a:t>Nemotron via Nightshift: two sentences; rejected or unavailable → labelled ledger text</a:t>
+              <a:t>Nemotron drafts two sentences; a second Nemotron call critiques them against the facts → one revision, else labelled ledger text</a:t>
             </a:r>
           </a:p>
         </p:txBody>
@@ -4908,7 +4908,7 @@
                 </a:solidFill>
                 <a:latin typeface="Calibri"/>
               </a:rPr>
-              <a:t>Real code paths, with tests: retry, escalation, fallback when the provider is down, replay of recorded traces in sample mode (no key, no network).</a:t>
+              <a:t>Real code paths, with tests: critique → revision loop, retry, escalation, fallback when the provider is down, replay of recorded traces in sample mode (no key, no network).</a:t>
             </a:r>
           </a:p>
         </p:txBody>

</xml_diff>

<commit_message>
Nightshift live run: not run (Nightshift not listening, no runtime key); docs, deck and output examples updated
Nemotron nemotron-3-nano-30b-a3b-nvfp4 was up on vLLM 127.0.0.1:8002; no Nightshift smoke,
live scenario or comparison ran, so no number is claimed. Zetaris and Meterless stay not integrated.

Co-Authored-By: Claude Opus 5.5 <noreply@anthropic.com>
</commit_message>
<xml_diff>
--- a/docs/deck/GMAPS_Open_Agent_2026.pptx
+++ b/docs/deck/GMAPS_Open_Agent_2026.pptx
@@ -5195,7 +5195,7 @@
                 </a:solidFill>
                 <a:latin typeface="Calibri"/>
               </a:rPr>
-              <a:t>Residue parse and the two-sentence explanation of every warning, through Nightshift (OpenAI-compatible). model_reported is logged on every call. Live run on the Spark pending at the time this deck was written.</a:t>
+              <a:t>Residue parse and the two-sentence explanation of every warning, through Nightshift (OpenAI-compatible). model_reported is logged on every call. Nightshift live run: not run.</a:t>
             </a:r>
           </a:p>
         </p:txBody>
@@ -5983,7 +5983,7 @@
                 </a:solidFill>
                 <a:latin typeface="Calibri"/>
               </a:rPr>
-              <a:t>NightshiftLLM (OpenAI-compatible, key from the environment, temperature 0, one retry on 5xx, typed "provider_unavailable"). It is the primary provider for every model call in the loop. Live Nemotron run on the Spark pending at time of writing.</a:t>
+              <a:t>NightshiftLLM (OpenAI-compatible, key from the environment, temperature 0, one retry on 5xx, typed "provider_unavailable"). It is the primary provider for every model call in the loop. Nightshift live run: not run.</a:t>
             </a:r>
           </a:p>
           <a:p>

</xml_diff>